<commit_message>
AI_LOG no formato do PA1, trabalho individual; slides sem dupla
</commit_message>
<xml_diff>
--- a/PA2_apresentacao.pptx
+++ b/PA2_apresentacao.pptx
@@ -122,50 +122,50 @@
   <p:extLst>
     <p:ext uri="{521415D9-36F7-43E2-AB2F-B90AF26B5E84}">
       <p14:sectionLst xmlns:p14="http://schemas.microsoft.com/office/powerpoint/2010/main">
-        <p14:section name="Abertura" id="{161e3643-9c1b-24a0-da99-a067166a0bd8}">
+        <p14:section name="Abertura" id="{e81179a7-1df6-2817-4440-30f3d6394762}">
           <p14:sldIdLst>
             <p14:sldId id="256"/>
           </p14:sldIdLst>
         </p14:section>
-        <p14:section name="Problema" id="{c8fba1fe-d691-13b6-caa9-af2af982f0c4}">
+        <p14:section name="Problema" id="{204158c5-0128-7f1f-4b9d-082f27980c58}">
           <p14:sldIdLst>
             <p14:sldId id="257"/>
             <p14:sldId id="258"/>
           </p14:sldIdLst>
         </p14:section>
-        <p14:section name="Sintético" id="{72b30cfb-4ee0-7d04-4de4-e35e300d8f89}">
+        <p14:section name="Sintético" id="{2e74e542-696b-25a9-fafb-7c0dc1cba5ea}">
           <p14:sldIdLst>
             <p14:sldId id="259"/>
             <p14:sldId id="260"/>
           </p14:sldIdLst>
         </p14:section>
-        <p14:section name="Trilha A" id="{a2980696-c8d2-6a9c-a3a9-e774fe99e896}">
+        <p14:section name="Trilha A" id="{a3224651-5390-2c43-3e40-c3c7c1a479bc}">
           <p14:sldIdLst>
             <p14:sldId id="261"/>
             <p14:sldId id="262"/>
             <p14:sldId id="263"/>
           </p14:sldIdLst>
         </p14:section>
-        <p14:section name="Ablação e falhas" id="{0a85d176-4f3f-5de0-781f-554d50665043}">
+        <p14:section name="Ablação e falhas" id="{5ce9a6c8-8fc5-4257-7ca9-83ff270c5e11}">
           <p14:sldIdLst>
             <p14:sldId id="264"/>
             <p14:sldId id="265"/>
             <p14:sldId id="266"/>
           </p14:sldIdLst>
         </p14:section>
-        <p14:section name="Estresse" id="{d04f785b-52e7-3908-1856-8cb2fcdcc54a}">
+        <p14:section name="Estresse" id="{0a8aa061-f618-0bf4-f7fa-03a61510a092}">
           <p14:sldIdLst>
             <p14:sldId id="267"/>
           </p14:sldIdLst>
         </p14:section>
-        <p14:section name="MOT17 real" id="{8767baff-b43e-226c-42e5-1d253f889071}">
+        <p14:section name="MOT17 real" id="{23a7212d-f535-0073-e57f-5961e2366dba}">
           <p14:sldIdLst>
             <p14:sldId id="268"/>
             <p14:sldId id="269"/>
             <p14:sldId id="270"/>
           </p14:sldIdLst>
         </p14:section>
-        <p14:section name="Conclusão" id="{9fd335d6-0c7f-c6f5-2768-d661483b6471}">
+        <p14:section name="Conclusão" id="{be0c6c42-7497-2066-e473-313b0327e350}">
           <p14:sldIdLst>
             <p14:sldId id="271"/>
           </p14:sldIdLst>
@@ -3169,7 +3169,7 @@
           <a:p>
             <a:r>
               <a:rPr lang="en-US" dirty="0"/>
-              <a:t>Abertura. O objetivo do PA2 é sair da detecção quadro a quadro (o que o detector vê em cada imagem) para a identidade ao longo do tempo: saber que a pessoa do quadro 10 é a mesma do quadro 200. Escolhemos a Trilha A: uma RNN que aprende o movimento de cada objeto e ajuda a associar detecções entre quadros.</a:t>
+              <a:t>Abertura. O objetivo do PA2 é sair da detecção quadro a quadro (o que o detector vê em cada imagem) para a identidade ao longo do tempo: saber que a pessoa do quadro 10 é a mesma do quadro 200. Escolhi a Trilha A: uma RNN que aprende o movimento de cada objeto e ajuda a associar detecções entre quadros.</a:t>
             </a:r>
             <a:endParaRPr lang="en-US" dirty="0"/>
           </a:p>
@@ -3433,7 +3433,7 @@
           <a:p>
             <a:r>
               <a:rPr lang="en-US" dirty="0"/>
-              <a:t>Estresse sem retreinar: degradamos o detector em três níveis (drop, ruído de caixa, falsos positivos). Em leve e média a RNN absorve — o IDF1 relativo cai menos que o mAP relativo. Na forte ela amplifica: switches multiplicam por 13 e o Kalman, com ruído de processo explícito, degrada com mais suavidade. Motivo: ruído de 10% está fora da distribuição de treino. Correção natural: treinar com ruído variável ou usar o score como confiança da observação. Pergunta extra da taxa de quadros: um modelo treinado com Δt fixo aprende 'deslocamento por passo'; subamostrar quebra isso; dar Δt como entrada só ajuda se o treino vir vários Δt.</a:t>
+              <a:t>Estresse sem retreinar: degradei o detector em três níveis (drop, ruído de caixa, falsos positivos). Em leve e média a RNN absorve — o IDF1 relativo cai menos que o mAP relativo. Na forte ela amplifica: switches multiplicam por 13 e o Kalman, com ruído de processo explícito, degrada com mais suavidade. Motivo: ruído de 10% está fora da distribuição de treino. Correção natural: treinar com ruído variável ou usar o score como confiança da observação. Pergunta extra da taxa de quadros: um modelo treinado com Δt fixo aprende 'deslocamento por passo'; subamostrar quebra isso; dar Δt como entrada só ajuda se o treino vir vários Δt.</a:t>
             </a:r>
             <a:endParaRPr lang="en-US" dirty="0"/>
           </a:p>
@@ -3521,7 +3521,7 @@
           <a:p>
             <a:r>
               <a:rPr lang="en-US" dirty="0"/>
-              <a:t>Agora o MOT17 real, nas sequências de teste 10 e 13, com as detecções públicas FRCNN. O mAP do detector é só 0,59: o problema já começa difícil. O IoU ingênuo cria 3,3 vezes mais ids do que existem. Kalman e RNN ficam praticamente empatados: a RNN tem IDF1 0,500 contra 0,493 e 383 contra 397 switches. Temos que ser honestos: no sintético a vantagem da RNN vinha de movimento não linear (quicadas, aceleração aleatória). Pedestres andam quase em linha reta, e aí o Kalman de velocidade constante já captura quase tudo. Além disso o Kalman preserva mais oclusões e erra menos a contagem; a RNN fragmenta mais. Mas são só cerca de 45 eventos de oclusão em 2 sequências, então essa diferença tem muita variância. Também rodamos o detector do torchvision (Faster R-CNN v2) na GPU do Mac. Ele tem mAP 0,647, bem acima do FRCNN público, e mesmo assim o IoU ingênuo piora (0,410 → 0,372), porque o detector gera quase o dobro de caixas e a associação ingênua se confunde mais. A RNN é a única que aproveita o detector melhor: IDF1 0,517 e 350 switches, contra 513 do Kalman. É o descolamento da Parte 1 na direção oposta: detector melhor não conserta a identidade.</a:t>
+              <a:t>Agora o MOT17 real, nas sequências de teste 10 e 13, com as detecções públicas FRCNN. O mAP do detector é só 0,59: o problema já começa difícil. O IoU ingênuo cria 3,3 vezes mais ids do que existem. Kalman e RNN ficam praticamente empatados: a RNN tem IDF1 0,500 contra 0,493 e 383 contra 397 switches. É preciso ser honesto: no sintético a vantagem da RNN vinha de movimento não linear (quicadas, aceleração aleatória). Pedestres andam quase em linha reta, e aí o Kalman de velocidade constante já captura quase tudo. Além disso o Kalman preserva mais oclusões e erra menos a contagem; a RNN fragmenta mais. Mas são só cerca de 45 eventos de oclusão em 2 sequências, então essa diferença tem muita variância. Também rodei o detector do torchvision (Faster R-CNN v2) na GPU do Mac. Ele tem mAP 0,647, bem acima do FRCNN público, e mesmo assim o IoU ingênuo piora (0,410 → 0,372), porque o detector gera quase o dobro de caixas e a associação ingênua se confunde mais. A RNN é a única que aproveita o detector melhor: IDF1 0,517 e 350 switches, contra 513 do Kalman. É o descolamento da Parte 1 na direção oposta: detector melhor não conserta a identidade.</a:t>
             </a:r>
             <a:endParaRPr lang="en-US" dirty="0"/>
           </a:p>
@@ -3609,7 +3609,7 @@
           <a:p>
             <a:r>
               <a:rPr lang="en-US" dirty="0"/>
-              <a:t>Rodamos as mesmas Partes 3, 4 e 5 no MOT17. Ablação: a validação é uma única sequência (MOT17-09), então o IDF1 oscila entre 0,51 e 0,59 sem tendência clara entre células ou janelas — não dá para concluir nada sobre a célula. O que se repete é que a sobrevivência à oclusão cresce com T. Correção da Parte 4: aumentar T, buracos de treino e max_age melhora a sobrevivência à oclusão de 40% para 51%, mas manter tracks vivas por mais tempo também gera mais trocas em cenas densas, e o IDF1 fica igual. O próximo slide mostra por quê. Estresse: o padrão do sintético se repete — a RNN absorve degradação leve e média e perde para o Kalman na forte.</a:t>
+              <a:t>Rodei as mesmas Partes 3, 4 e 5 no MOT17. Ablação: a validação é uma única sequência (MOT17-09), então o IDF1 oscila entre 0,51 e 0,59 sem tendência clara entre células ou janelas — não dá para concluir nada sobre a célula. O que se repete é que a sobrevivência à oclusão cresce com T. Correção da Parte 4: aumentar T, buracos de treino e max_age melhora a sobrevivência à oclusão de 40% para 51%, mas manter tracks vivas por mais tempo também gera mais trocas em cenas densas, e o IDF1 fica igual. O próximo slide mostra por quê. Estresse: o padrão do sintético se repete — a RNN absorve degradação leve e média e perde para o Kalman na forte.</a:t>
             </a:r>
             <a:endParaRPr lang="en-US" dirty="0"/>
           </a:p>
@@ -3873,7 +3873,7 @@
           <a:p>
             <a:r>
               <a:rPr lang="en-US" dirty="0"/>
-              <a:t>Pipeline em 4 passos. 1) O detector é congelado: usamos as detecções prontas do MOT17 (FRCNN) ou o simulador no sintético. 2) Cada track tem um estado GRU que prevê onde o objeto estará no próximo quadro, com uma variância. 3) Associamos detecções a tracks pelo IoU com a caixa prevista, e aceitamos também pares com IoU baixo se a distância de Mahalanobis (usando a variância prevista) for pequena — é o 'portão adaptativo', que abre quando a incerteza cresce numa oclusão. Matching guloso: confirmadas primeiro, depois tentativas. 4) Uma detecção sem par nasce como tentativa e vira confirmada após min_hits; uma track confirmada morre após max_age quadros sem ser vista; enquanto ocluída, a RNN roda para frente alimentada pela própria previsão.</a:t>
+              <a:t>Pipeline em 4 passos. 1) O detector é congelado: uso as detecções prontas do MOT17 (FRCNN) ou o simulador no sintético. 2) Cada track tem um estado GRU que prevê onde o objeto estará no próximo quadro, com uma variância. 3) Associo detecções a tracks pelo IoU com a caixa prevista, e aceito também pares com IoU baixo se a distância de Mahalanobis (usando a variância prevista) for pequena — é o 'portão adaptativo', que abre quando a incerteza cresce numa oclusão. Matching guloso: confirmadas primeiro, depois tentativas. 4) Uma detecção sem par nasce como tentativa e vira confirmada após min_hits; uma track confirmada morre após max_age quadros sem ser vista; enquanto ocluída, a RNN roda para frente alimentada pela própria previsão.</a:t>
             </a:r>
             <a:endParaRPr lang="en-US" dirty="0"/>
           </a:p>
@@ -3961,7 +3961,7 @@
           <a:p>
             <a:r>
               <a:rPr lang="en-US" dirty="0"/>
-              <a:t>As métricas foram escritas do zero em metrics.py. IDF1: casamos ids previstos com ids verdadeiros usando o Hungarian sobre o número de quadros em comum (IoU &gt;= 0,5), e IDF1 = 2·IDTP / (2·IDTP + IDFP + IDFN). ID switch: conta quando o id previsto associado a um objeto verdadeiro muda entre quadros. Fragmentação: quando a cobertura de um objeto é interrompida e retomada. Os testes (a), (b), (c) mostram que IDSW e IDF1 medem coisas diferentes: (b) troca no meio — 2 switches, IDF1 0,5; (c) partição — 1 switch, 1 fragmentação, IDF1 0,769 e uma identidade a mais.</a:t>
+              <a:t>As métricas foram escritas do zero em metrics.py. IDF1: caso ids previstos com ids verdadeiros usando o Hungarian sobre o número de quadros em comum (IoU &gt;= 0,5), e IDF1 = 2·IDTP / (2·IDTP + IDFP + IDFN). ID switch: conta quando o id previsto associado a um objeto verdadeiro muda entre quadros. Fragmentação: quando a cobertura de um objeto é interrompida e retomada. Os testes (a), (b), (c) mostram que IDSW e IDF1 medem coisas diferentes: (b) troca no meio — 2 switches, IDF1 0,5; (c) partição — 1 switch, 1 fragmentação, IDF1 0,769 e uma identidade a mais.</a:t>
             </a:r>
             <a:endParaRPr lang="en-US" dirty="0"/>
           </a:p>
@@ -4049,7 +4049,7 @@
           <a:p>
             <a:r>
               <a:rPr lang="en-US" dirty="0"/>
-              <a:t>Construímos o próprio gerador para controlar cada fator isoladamente. A visibilidade é calculada pela fração de pixels da elipse que continuam visíveis — o mesmo campo visibility do MOT17. A varredura mostrou: mais objetos derruba pouco (0,92 → 0,79), velocidade derruba muito (0,91 → 0,45) porque com caixas de ~10 px o IoU entre quadros some, e oclusão derruba no primeiro degrau e satura, porque com k=3 qualquer oclusão &gt; 3 quadros já vira id novo.</a:t>
+              <a:t>Construí o próprio gerador para controlar cada fator isoladamente. A visibilidade é calculada pela fração de pixels da elipse que continuam visíveis — o mesmo campo visibility do MOT17. A varredura mostrou: mais objetos derruba pouco (0,92 → 0,79), velocidade derruba muito (0,91 → 0,45) porque com caixas de ~10 px o IoU entre quadros some, e oclusão derruba no primeiro degrau e satura, porque com k=3 qualquer oclusão &gt; 3 quadros já vira id novo.</a:t>
             </a:r>
             <a:endParaRPr lang="en-US" dirty="0"/>
           </a:p>
@@ -4137,7 +4137,7 @@
           <a:p>
             <a:r>
               <a:rPr lang="en-US" dirty="0"/>
-              <a:t>Mensagem central da Parte 1: medir só o detector engana. Em 10 vídeos de dificuldade crescente, o mAP fica quase plano mas o IDF1 cai pela metade, a razão ids previstas / ids verdadeiros sobe de 1,0 para 2,05 e os switches por identidade vão de 0 a 1,8. A associação ingênua usa a última caixa observada como referência: com movimento rápido o IoU não fecha e, na oclusão, a referência fica parada. Escolhemos os hiperparâmetros na validação (sementes 2000+), nunca no teste. O Hungarian maximiza o número de pares e acaba aceitando casamentos ruins que o guloso deixaria livres.</a:t>
+              <a:t>Mensagem central da Parte 1: medir só o detector engana. Em 10 vídeos de dificuldade crescente, o mAP fica quase plano mas o IDF1 cai pela metade, a razão ids previstas / ids verdadeiros sobe de 1,0 para 2,05 e os switches por identidade vão de 0 a 1,8. A associação ingênua usa a última caixa observada como referência: com movimento rápido o IoU não fecha e, na oclusão, a referência fica parada. Escolhi os hiperparâmetros na validação (sementes 2000+), nunca no teste. O Hungarian maximiza o número de pares e acaba aceitando casamentos ruins que o guloso deixaria livres.</a:t>
             </a:r>
             <a:endParaRPr lang="en-US" dirty="0"/>
           </a:p>
@@ -4225,7 +4225,7 @@
           <a:p>
             <a:r>
               <a:rPr lang="en-US" dirty="0"/>
-              <a:t>Por que Trilha A: ela treina só com trajetórias da ground truth e roda só com o det.txt — não precisa das imagens. A recorrência carrega, por track, a memória do movimento: velocidade, aceleração, quicadas. A entrada é relativa (deltas normalizados pela altura), então o modelo vale para qualquer posição e escala. A saída é uma gaussiana: média e variância do próximo deslocamento. Treinamos com scheduled sampling — às vezes alimentamos a própria previsão em vez da observação — para o modelo aprender a andar sozinho durante oclusões. A perda de NLL treina a variância a ser honesta, e é essa variância que define o portão adaptativo de associação.</a:t>
+              <a:t>Por que Trilha A: ela treina só com trajetórias da ground truth e roda só com o det.txt — não precisa das imagens. A recorrência carrega, por track, a memória do movimento: velocidade, aceleração, quicadas. A entrada é relativa (deltas normalizados pela altura), então o modelo vale para qualquer posição e escala. A saída é uma gaussiana: média e variância do próximo deslocamento. Treino com scheduled sampling — às vezes alimento a própria previsão em vez da observação — para o modelo aprender a andar sozinho durante oclusões. A perda de NLL treina a variância a ser honesta, e é essa variância que define o portão adaptativo de associação.</a:t>
             </a:r>
             <a:endParaRPr lang="en-US" dirty="0"/>
           </a:p>
@@ -5485,7 +5485,7 @@
                   <a:schemeClr val="accent5"/>
                 </a:solidFill>
               </a:rPr>
-              <a:t>Dupla: Yoni Rabinovici Gherman · ____________________</a:t>
+              <a:t>Yoni Rabinovici Gherman</a:t>
             </a:r>
             <a:endParaRPr lang="en-US" sz="1400" dirty="0"/>
           </a:p>
@@ -9892,7 +9892,7 @@
                   <a:schemeClr val="bg1"/>
                 </a:solidFill>
               </a:rPr>
-              <a:t>O que levamos</a:t>
+              <a:t>O que fica</a:t>
             </a:r>
             <a:endParaRPr lang="en-US" sz="3400" dirty="0"/>
           </a:p>
@@ -13166,7 +13166,7 @@
                   <a:schemeClr val="tx1"/>
                 </a:solidFill>
               </a:rPr>
-              <a:t>Os três testes de pytest passam (tests/test_metrics.py). Também implementamos MOTA, mAP, NMS e sobrevivência à oclusão em metrics.py.</a:t>
+              <a:t>Os três testes de pytest passam (tests/test_metrics.py). Também implementei MOTA, mAP, NMS e sobrevivência à oclusão em metrics.py.</a:t>
             </a:r>
             <a:endParaRPr lang="en-US" sz="1500" dirty="0"/>
           </a:p>

</xml_diff>

<commit_message>
Slides: nome na capa
</commit_message>
<xml_diff>
--- a/PA2_apresentacao.pptx
+++ b/PA2_apresentacao.pptx
@@ -122,50 +122,50 @@
   <p:extLst>
     <p:ext uri="{521415D9-36F7-43E2-AB2F-B90AF26B5E84}">
       <p14:sectionLst xmlns:p14="http://schemas.microsoft.com/office/powerpoint/2010/main">
-        <p14:section name="Abertura" id="{e81179a7-1df6-2817-4440-30f3d6394762}">
+        <p14:section name="Abertura" id="{ee3d14d1-4af0-8208-875d-348ce779c5ae}">
           <p14:sldIdLst>
             <p14:sldId id="256"/>
           </p14:sldIdLst>
         </p14:section>
-        <p14:section name="Problema" id="{204158c5-0128-7f1f-4b9d-082f27980c58}">
+        <p14:section name="Problema" id="{39a9c7fd-d8fc-e7f3-e836-e5785085aed7}">
           <p14:sldIdLst>
             <p14:sldId id="257"/>
             <p14:sldId id="258"/>
           </p14:sldIdLst>
         </p14:section>
-        <p14:section name="Sintético" id="{2e74e542-696b-25a9-fafb-7c0dc1cba5ea}">
+        <p14:section name="Sintético" id="{723099fb-2ccc-788e-90c8-08cc8097c3a7}">
           <p14:sldIdLst>
             <p14:sldId id="259"/>
             <p14:sldId id="260"/>
           </p14:sldIdLst>
         </p14:section>
-        <p14:section name="Trilha A" id="{a3224651-5390-2c43-3e40-c3c7c1a479bc}">
+        <p14:section name="Trilha A" id="{82d6b6cd-a708-7fe0-0284-9522a35ec8a6}">
           <p14:sldIdLst>
             <p14:sldId id="261"/>
             <p14:sldId id="262"/>
             <p14:sldId id="263"/>
           </p14:sldIdLst>
         </p14:section>
-        <p14:section name="Ablação e falhas" id="{5ce9a6c8-8fc5-4257-7ca9-83ff270c5e11}">
+        <p14:section name="Ablação e falhas" id="{d1a334c5-2a4f-327d-49fa-4ce77f52eed6}">
           <p14:sldIdLst>
             <p14:sldId id="264"/>
             <p14:sldId id="265"/>
             <p14:sldId id="266"/>
           </p14:sldIdLst>
         </p14:section>
-        <p14:section name="Estresse" id="{0a8aa061-f618-0bf4-f7fa-03a61510a092}">
+        <p14:section name="Estresse" id="{6e100422-a47e-5ac6-1a21-02867a020064}">
           <p14:sldIdLst>
             <p14:sldId id="267"/>
           </p14:sldIdLst>
         </p14:section>
-        <p14:section name="MOT17 real" id="{23a7212d-f535-0073-e57f-5961e2366dba}">
+        <p14:section name="MOT17 real" id="{98312c13-e88a-a88f-1fbe-a037b501a0cc}">
           <p14:sldIdLst>
             <p14:sldId id="268"/>
             <p14:sldId id="269"/>
             <p14:sldId id="270"/>
           </p14:sldIdLst>
         </p14:section>
-        <p14:section name="Conclusão" id="{be0c6c42-7497-2066-e473-313b0327e350}">
+        <p14:section name="Conclusão" id="{87be49c5-fb16-3f50-5218-24cc68ef93a0}">
           <p14:sldIdLst>
             <p14:sldId id="271"/>
           </p14:sldIdLst>
@@ -5485,7 +5485,7 @@
                   <a:schemeClr val="accent5"/>
                 </a:solidFill>
               </a:rPr>
-              <a:t>Yoni Rabinovici Gherman</a:t>
+              <a:t>Yonathan Rabinovici Gherman</a:t>
             </a:r>
             <a:endParaRPr lang="en-US" sz="1400" dirty="0"/>
           </a:p>

</xml_diff>